<commit_message>
update lab - more to do
</commit_message>
<xml_diff>
--- a/topic01-objects-and-classes/unit-1/talk-0/Understanding_the_JVM.pptx
+++ b/topic01-objects-and-classes/unit-1/talk-0/Understanding_the_JVM.pptx
@@ -554,7 +554,7 @@
               </a14:hiddenLine>
             </a:ext>
             <a:ext uri="{FAA26D3D-D897-4be2-8F04-BA451C77F1D7}">
-              <ma14:placeholderFlag xmlns:ma14="http://schemas.microsoft.com/office/mac/drawingml/2011/main" xmlns="" val="1"/>
+              <ma14:placeholderFlag xmlns="" xmlns:ma14="http://schemas.microsoft.com/office/mac/drawingml/2011/main" val="1"/>
             </a:ext>
           </a:extLst>
         </p:spPr>
@@ -5094,9 +5094,15 @@
       </p:sp>
       <p:pic>
         <p:nvPicPr>
-          <p:cNvPr id="3074" name="Picture 2" descr="Image result for questions"/>
+          <p:cNvPr id="4" name="Picture 3" descr="A green question mark in a circle&#10;&#10;AI-generated content may be incorrect.">
+            <a:extLst>
+              <a:ext uri="{FF2B5EF4-FFF2-40B4-BE49-F238E27FC236}">
+                <a16:creationId xmlns:a16="http://schemas.microsoft.com/office/drawing/2014/main" id="{EA9FEA22-4755-30D5-B4EC-3188286FD808}"/>
+              </a:ext>
+            </a:extLst>
+          </p:cNvPr>
           <p:cNvPicPr>
-            <a:picLocks noChangeAspect="1" noChangeArrowheads="1"/>
+            <a:picLocks noChangeAspect="1"/>
           </p:cNvPicPr>
           <p:nvPr/>
         </p:nvPicPr>
@@ -5108,29 +5114,18 @@
               </a:ext>
             </a:extLst>
           </a:blip>
-          <a:srcRect/>
           <a:stretch>
             <a:fillRect/>
           </a:stretch>
         </p:blipFill>
-        <p:spPr bwMode="auto">
+        <p:spPr>
           <a:xfrm>
-            <a:off x="3810000" y="2057401"/>
-            <a:ext cx="4343400" cy="3509469"/>
+            <a:off x="2971800" y="1325562"/>
+            <a:ext cx="5257800" cy="5257800"/>
           </a:xfrm>
           <a:prstGeom prst="rect">
             <a:avLst/>
           </a:prstGeom>
-          <a:noFill/>
-          <a:extLst>
-            <a:ext uri="{909E8E84-426E-40DD-AFC4-6F175D3DCCD1}">
-              <a14:hiddenFill xmlns:a14="http://schemas.microsoft.com/office/drawing/2010/main">
-                <a:solidFill>
-                  <a:srgbClr val="FFFFFF"/>
-                </a:solidFill>
-              </a14:hiddenFill>
-            </a:ext>
-          </a:extLst>
         </p:spPr>
       </p:pic>
     </p:spTree>

</xml_diff>